<commit_message>
Add OG meta tags, fix mobile header and watermark rendering
- Add Open Graph + Twitter card meta tags for social link previews
- Generate 1200x630 OG image at /og-image.png
- Mobile header: hide brand descriptor below 560px viewport
- Fix deck watermark — solid colors instead of alpha XML for PowerPoint compatibility
- Regenerate inflammation-biologic-defense-deck.pptx
</commit_message>
<xml_diff>
--- a/public/examples/inflammation-biologic-defense-deck.pptx
+++ b/public/examples/inflammation-biologic-defense-deck.pptx
@@ -3104,7 +3104,42 @@
       <p:grpSpPr/>
       <p:sp>
         <p:nvSpPr>
-          <p:cNvPr id="2" name="Rectangle 1"/>
+          <p:cNvPr id="2" name="TextBox 1"/>
+          <p:cNvSpPr txBox="1"/>
+          <p:nvPr/>
+        </p:nvSpPr>
+        <p:spPr>
+          <a:xfrm rot="19800000">
+            <a:off x="-762152" y="2423160"/>
+            <a:ext cx="13716000" cy="2011680"/>
+          </a:xfrm>
+          <a:prstGeom prst="rect">
+            <a:avLst/>
+          </a:prstGeom>
+          <a:noFill/>
+        </p:spPr>
+        <p:txBody>
+          <a:bodyPr wrap="none" lIns="0" rIns="0" tIns="0" bIns="0" anchor="ctr">
+            <a:spAutoFit/>
+          </a:bodyPr>
+          <a:lstStyle/>
+          <a:p>
+            <a:pPr algn="ctr"/>
+            <a:r>
+              <a:rPr sz="8000" b="1">
+                <a:solidFill>
+                  <a:srgbClr val="4A558C"/>
+                </a:solidFill>
+                <a:latin typeface="Cambria"/>
+              </a:rPr>
+              <a:t>WORKED EXAMPLE  ·  FICTIONAL BRAND</a:t>
+            </a:r>
+          </a:p>
+        </p:txBody>
+      </p:sp>
+      <p:sp>
+        <p:nvSpPr>
+          <p:cNvPr id="3" name="Rectangle 2"/>
           <p:cNvSpPr/>
           <p:nvPr/>
         </p:nvSpPr>
@@ -3148,7 +3183,7 @@
       </p:sp>
       <p:sp>
         <p:nvSpPr>
-          <p:cNvPr id="3" name="TextBox 2"/>
+          <p:cNvPr id="4" name="TextBox 3"/>
           <p:cNvSpPr txBox="1"/>
           <p:nvPr/>
         </p:nvSpPr>
@@ -3187,7 +3222,7 @@
       </p:sp>
       <p:sp>
         <p:nvSpPr>
-          <p:cNvPr id="4" name="TextBox 3"/>
+          <p:cNvPr id="5" name="TextBox 4"/>
           <p:cNvSpPr txBox="1"/>
           <p:nvPr/>
         </p:nvSpPr>
@@ -3226,7 +3261,7 @@
       </p:sp>
       <p:sp>
         <p:nvSpPr>
-          <p:cNvPr id="5" name="TextBox 4"/>
+          <p:cNvPr id="6" name="TextBox 5"/>
           <p:cNvSpPr txBox="1"/>
           <p:nvPr/>
         </p:nvSpPr>
@@ -3265,7 +3300,7 @@
       </p:sp>
       <p:sp>
         <p:nvSpPr>
-          <p:cNvPr id="6" name="Rectangle 5"/>
+          <p:cNvPr id="7" name="Rectangle 6"/>
           <p:cNvSpPr/>
           <p:nvPr/>
         </p:nvSpPr>
@@ -3311,7 +3346,7 @@
       </p:sp>
       <p:sp>
         <p:nvSpPr>
-          <p:cNvPr id="7" name="TextBox 6"/>
+          <p:cNvPr id="8" name="TextBox 7"/>
           <p:cNvSpPr txBox="1"/>
           <p:nvPr/>
         </p:nvSpPr>
@@ -3350,7 +3385,7 @@
       </p:sp>
       <p:sp>
         <p:nvSpPr>
-          <p:cNvPr id="8" name="TextBox 7"/>
+          <p:cNvPr id="9" name="TextBox 8"/>
           <p:cNvSpPr txBox="1"/>
           <p:nvPr/>
         </p:nvSpPr>
@@ -3389,7 +3424,7 @@
       </p:sp>
       <p:sp>
         <p:nvSpPr>
-          <p:cNvPr id="9" name="Rectangle 8"/>
+          <p:cNvPr id="10" name="Rectangle 9"/>
           <p:cNvSpPr/>
           <p:nvPr/>
         </p:nvSpPr>
@@ -3435,7 +3470,7 @@
       </p:sp>
       <p:sp>
         <p:nvSpPr>
-          <p:cNvPr id="10" name="TextBox 9"/>
+          <p:cNvPr id="11" name="TextBox 10"/>
           <p:cNvSpPr txBox="1"/>
           <p:nvPr/>
         </p:nvSpPr>
@@ -3474,7 +3509,7 @@
       </p:sp>
       <p:sp>
         <p:nvSpPr>
-          <p:cNvPr id="11" name="TextBox 10"/>
+          <p:cNvPr id="12" name="TextBox 11"/>
           <p:cNvSpPr txBox="1"/>
           <p:nvPr/>
         </p:nvSpPr>
@@ -3513,7 +3548,7 @@
       </p:sp>
       <p:sp>
         <p:nvSpPr>
-          <p:cNvPr id="12" name="Rectangle 11"/>
+          <p:cNvPr id="13" name="Rectangle 12"/>
           <p:cNvSpPr/>
           <p:nvPr/>
         </p:nvSpPr>
@@ -3559,7 +3594,7 @@
       </p:sp>
       <p:sp>
         <p:nvSpPr>
-          <p:cNvPr id="13" name="TextBox 12"/>
+          <p:cNvPr id="14" name="TextBox 13"/>
           <p:cNvSpPr txBox="1"/>
           <p:nvPr/>
         </p:nvSpPr>
@@ -3598,7 +3633,7 @@
       </p:sp>
       <p:sp>
         <p:nvSpPr>
-          <p:cNvPr id="14" name="TextBox 13"/>
+          <p:cNvPr id="15" name="TextBox 14"/>
           <p:cNvSpPr txBox="1"/>
           <p:nvPr/>
         </p:nvSpPr>
@@ -3637,7 +3672,46 @@
       </p:sp>
       <p:sp>
         <p:nvSpPr>
-          <p:cNvPr id="15" name="TextBox 14"/>
+          <p:cNvPr id="16" name="TextBox 15"/>
+          <p:cNvSpPr txBox="1"/>
+          <p:nvPr/>
+        </p:nvSpPr>
+        <p:spPr>
+          <a:xfrm>
+            <a:off x="640080" y="6199632"/>
+            <a:ext cx="10058400" cy="228600"/>
+          </a:xfrm>
+          <a:prstGeom prst="rect">
+            <a:avLst/>
+          </a:prstGeom>
+          <a:noFill/>
+        </p:spPr>
+        <p:txBody>
+          <a:bodyPr wrap="square" lIns="0" rIns="0" tIns="0" bIns="0" anchor="t">
+            <a:spAutoFit/>
+          </a:bodyPr>
+          <a:lstStyle/>
+          <a:p>
+            <a:pPr algn="l">
+              <a:lnSpc>
+                <a:spcPct val="115000"/>
+              </a:lnSpc>
+            </a:pPr>
+            <a:r>
+              <a:rPr sz="850" b="0" i="1">
+                <a:solidFill>
+                  <a:srgbClr val="F9C84D"/>
+                </a:solidFill>
+                <a:latin typeface="Calibri"/>
+              </a:rPr>
+              <a:t>Worked example  ·  fictional brand  ·  numbers directional from public benchmarks (Humira, Stelara, Remicade)</a:t>
+            </a:r>
+          </a:p>
+        </p:txBody>
+      </p:sp>
+      <p:sp>
+        <p:nvSpPr>
+          <p:cNvPr id="17" name="TextBox 16"/>
           <p:cNvSpPr txBox="1"/>
           <p:nvPr/>
         </p:nvSpPr>
@@ -3676,7 +3750,7 @@
       </p:sp>
       <p:sp>
         <p:nvSpPr>
-          <p:cNvPr id="16" name="TextBox 15"/>
+          <p:cNvPr id="18" name="TextBox 17"/>
           <p:cNvSpPr txBox="1"/>
           <p:nvPr/>
         </p:nvSpPr>
@@ -3746,6 +3820,41 @@
           <p:nvPr/>
         </p:nvSpPr>
         <p:spPr>
+          <a:xfrm rot="19800000">
+            <a:off x="-762152" y="2423160"/>
+            <a:ext cx="13716000" cy="2011680"/>
+          </a:xfrm>
+          <a:prstGeom prst="rect">
+            <a:avLst/>
+          </a:prstGeom>
+          <a:noFill/>
+        </p:spPr>
+        <p:txBody>
+          <a:bodyPr wrap="none" lIns="0" rIns="0" tIns="0" bIns="0" anchor="ctr">
+            <a:spAutoFit/>
+          </a:bodyPr>
+          <a:lstStyle/>
+          <a:p>
+            <a:pPr algn="ctr"/>
+            <a:r>
+              <a:rPr sz="8000" b="1">
+                <a:solidFill>
+                  <a:srgbClr val="C8CCD8"/>
+                </a:solidFill>
+                <a:latin typeface="Cambria"/>
+              </a:rPr>
+              <a:t>WORKED EXAMPLE  ·  FICTIONAL BRAND</a:t>
+            </a:r>
+          </a:p>
+        </p:txBody>
+      </p:sp>
+      <p:sp>
+        <p:nvSpPr>
+          <p:cNvPr id="3" name="TextBox 2"/>
+          <p:cNvSpPr txBox="1"/>
+          <p:nvPr/>
+        </p:nvSpPr>
+        <p:spPr>
           <a:xfrm>
             <a:off x="457200" y="411480"/>
             <a:ext cx="7315200" cy="274320"/>
@@ -3780,7 +3889,7 @@
       </p:sp>
       <p:sp>
         <p:nvSpPr>
-          <p:cNvPr id="3" name="TextBox 2"/>
+          <p:cNvPr id="4" name="TextBox 3"/>
           <p:cNvSpPr txBox="1"/>
           <p:nvPr/>
         </p:nvSpPr>
@@ -3819,7 +3928,7 @@
       </p:sp>
       <p:sp>
         <p:nvSpPr>
-          <p:cNvPr id="4" name="Rectangle 3"/>
+          <p:cNvPr id="5" name="Rectangle 4"/>
           <p:cNvSpPr/>
           <p:nvPr/>
         </p:nvSpPr>
@@ -3865,7 +3974,7 @@
       </p:sp>
       <p:sp>
         <p:nvSpPr>
-          <p:cNvPr id="5" name="Rectangle 4"/>
+          <p:cNvPr id="6" name="Rectangle 5"/>
           <p:cNvSpPr/>
           <p:nvPr/>
         </p:nvSpPr>
@@ -3909,7 +4018,7 @@
       </p:sp>
       <p:sp>
         <p:nvSpPr>
-          <p:cNvPr id="6" name="TextBox 5"/>
+          <p:cNvPr id="7" name="TextBox 6"/>
           <p:cNvSpPr txBox="1"/>
           <p:nvPr/>
         </p:nvSpPr>
@@ -3948,7 +4057,7 @@
       </p:sp>
       <p:sp>
         <p:nvSpPr>
-          <p:cNvPr id="7" name="TextBox 6"/>
+          <p:cNvPr id="8" name="TextBox 7"/>
           <p:cNvSpPr txBox="1"/>
           <p:nvPr/>
         </p:nvSpPr>
@@ -3987,7 +4096,7 @@
       </p:sp>
       <p:sp>
         <p:nvSpPr>
-          <p:cNvPr id="8" name="TextBox 7"/>
+          <p:cNvPr id="9" name="TextBox 8"/>
           <p:cNvSpPr txBox="1"/>
           <p:nvPr/>
         </p:nvSpPr>
@@ -4026,7 +4135,7 @@
       </p:sp>
       <p:sp>
         <p:nvSpPr>
-          <p:cNvPr id="9" name="Rectangle 8"/>
+          <p:cNvPr id="10" name="Rectangle 9"/>
           <p:cNvSpPr/>
           <p:nvPr/>
         </p:nvSpPr>
@@ -4072,7 +4181,7 @@
       </p:sp>
       <p:sp>
         <p:nvSpPr>
-          <p:cNvPr id="10" name="Rectangle 9"/>
+          <p:cNvPr id="11" name="Rectangle 10"/>
           <p:cNvSpPr/>
           <p:nvPr/>
         </p:nvSpPr>
@@ -4116,7 +4225,7 @@
       </p:sp>
       <p:sp>
         <p:nvSpPr>
-          <p:cNvPr id="11" name="TextBox 10"/>
+          <p:cNvPr id="12" name="TextBox 11"/>
           <p:cNvSpPr txBox="1"/>
           <p:nvPr/>
         </p:nvSpPr>
@@ -4155,7 +4264,7 @@
       </p:sp>
       <p:sp>
         <p:nvSpPr>
-          <p:cNvPr id="12" name="TextBox 11"/>
+          <p:cNvPr id="13" name="TextBox 12"/>
           <p:cNvSpPr txBox="1"/>
           <p:nvPr/>
         </p:nvSpPr>
@@ -4194,7 +4303,7 @@
       </p:sp>
       <p:sp>
         <p:nvSpPr>
-          <p:cNvPr id="13" name="TextBox 12"/>
+          <p:cNvPr id="14" name="TextBox 13"/>
           <p:cNvSpPr txBox="1"/>
           <p:nvPr/>
         </p:nvSpPr>
@@ -4233,7 +4342,7 @@
       </p:sp>
       <p:sp>
         <p:nvSpPr>
-          <p:cNvPr id="14" name="Rectangle 13"/>
+          <p:cNvPr id="15" name="Rectangle 14"/>
           <p:cNvSpPr/>
           <p:nvPr/>
         </p:nvSpPr>
@@ -4279,7 +4388,7 @@
       </p:sp>
       <p:sp>
         <p:nvSpPr>
-          <p:cNvPr id="15" name="Rectangle 14"/>
+          <p:cNvPr id="16" name="Rectangle 15"/>
           <p:cNvSpPr/>
           <p:nvPr/>
         </p:nvSpPr>
@@ -4323,7 +4432,7 @@
       </p:sp>
       <p:sp>
         <p:nvSpPr>
-          <p:cNvPr id="16" name="TextBox 15"/>
+          <p:cNvPr id="17" name="TextBox 16"/>
           <p:cNvSpPr txBox="1"/>
           <p:nvPr/>
         </p:nvSpPr>
@@ -4362,7 +4471,7 @@
       </p:sp>
       <p:sp>
         <p:nvSpPr>
-          <p:cNvPr id="17" name="TextBox 16"/>
+          <p:cNvPr id="18" name="TextBox 17"/>
           <p:cNvSpPr txBox="1"/>
           <p:nvPr/>
         </p:nvSpPr>
@@ -4401,7 +4510,7 @@
       </p:sp>
       <p:sp>
         <p:nvSpPr>
-          <p:cNvPr id="18" name="TextBox 17"/>
+          <p:cNvPr id="19" name="TextBox 18"/>
           <p:cNvSpPr txBox="1"/>
           <p:nvPr/>
         </p:nvSpPr>
@@ -4440,7 +4549,7 @@
       </p:sp>
       <p:sp>
         <p:nvSpPr>
-          <p:cNvPr id="19" name="TextBox 18"/>
+          <p:cNvPr id="20" name="TextBox 19"/>
           <p:cNvSpPr txBox="1"/>
           <p:nvPr/>
         </p:nvSpPr>
@@ -4479,7 +4588,7 @@
       </p:sp>
       <p:sp>
         <p:nvSpPr>
-          <p:cNvPr id="20" name="TextBox 19"/>
+          <p:cNvPr id="21" name="TextBox 20"/>
           <p:cNvSpPr txBox="1"/>
           <p:nvPr/>
         </p:nvSpPr>
@@ -4518,7 +4627,7 @@
       </p:sp>
       <p:sp>
         <p:nvSpPr>
-          <p:cNvPr id="21" name="TextBox 20"/>
+          <p:cNvPr id="22" name="TextBox 21"/>
           <p:cNvSpPr txBox="1"/>
           <p:nvPr/>
         </p:nvSpPr>
@@ -4588,6 +4697,41 @@
           <p:nvPr/>
         </p:nvSpPr>
         <p:spPr>
+          <a:xfrm rot="19800000">
+            <a:off x="-762152" y="2423160"/>
+            <a:ext cx="13716000" cy="2011680"/>
+          </a:xfrm>
+          <a:prstGeom prst="rect">
+            <a:avLst/>
+          </a:prstGeom>
+          <a:noFill/>
+        </p:spPr>
+        <p:txBody>
+          <a:bodyPr wrap="none" lIns="0" rIns="0" tIns="0" bIns="0" anchor="ctr">
+            <a:spAutoFit/>
+          </a:bodyPr>
+          <a:lstStyle/>
+          <a:p>
+            <a:pPr algn="ctr"/>
+            <a:r>
+              <a:rPr sz="8000" b="1">
+                <a:solidFill>
+                  <a:srgbClr val="C8CCD8"/>
+                </a:solidFill>
+                <a:latin typeface="Cambria"/>
+              </a:rPr>
+              <a:t>WORKED EXAMPLE  ·  FICTIONAL BRAND</a:t>
+            </a:r>
+          </a:p>
+        </p:txBody>
+      </p:sp>
+      <p:sp>
+        <p:nvSpPr>
+          <p:cNvPr id="3" name="TextBox 2"/>
+          <p:cNvSpPr txBox="1"/>
+          <p:nvPr/>
+        </p:nvSpPr>
+        <p:spPr>
           <a:xfrm>
             <a:off x="457200" y="411480"/>
             <a:ext cx="7315200" cy="274320"/>
@@ -4622,7 +4766,7 @@
       </p:sp>
       <p:sp>
         <p:nvSpPr>
-          <p:cNvPr id="3" name="TextBox 2"/>
+          <p:cNvPr id="4" name="TextBox 3"/>
           <p:cNvSpPr txBox="1"/>
           <p:nvPr/>
         </p:nvSpPr>
@@ -4661,7 +4805,7 @@
       </p:sp>
       <p:sp>
         <p:nvSpPr>
-          <p:cNvPr id="4" name="TextBox 3"/>
+          <p:cNvPr id="5" name="TextBox 4"/>
           <p:cNvSpPr txBox="1"/>
           <p:nvPr/>
         </p:nvSpPr>
@@ -4700,7 +4844,7 @@
       </p:sp>
       <p:sp>
         <p:nvSpPr>
-          <p:cNvPr id="5" name="Rectangle 4"/>
+          <p:cNvPr id="6" name="Rectangle 5"/>
           <p:cNvSpPr/>
           <p:nvPr/>
         </p:nvSpPr>
@@ -4744,7 +4888,7 @@
       </p:sp>
       <p:sp>
         <p:nvSpPr>
-          <p:cNvPr id="6" name="TextBox 5"/>
+          <p:cNvPr id="7" name="TextBox 6"/>
           <p:cNvSpPr txBox="1"/>
           <p:nvPr/>
         </p:nvSpPr>
@@ -4783,7 +4927,7 @@
       </p:sp>
       <p:sp>
         <p:nvSpPr>
-          <p:cNvPr id="7" name="TextBox 6"/>
+          <p:cNvPr id="8" name="TextBox 7"/>
           <p:cNvSpPr txBox="1"/>
           <p:nvPr/>
         </p:nvSpPr>
@@ -4822,7 +4966,7 @@
       </p:sp>
       <p:sp>
         <p:nvSpPr>
-          <p:cNvPr id="8" name="TextBox 7"/>
+          <p:cNvPr id="9" name="TextBox 8"/>
           <p:cNvSpPr txBox="1"/>
           <p:nvPr/>
         </p:nvSpPr>
@@ -4861,7 +5005,7 @@
       </p:sp>
       <p:sp>
         <p:nvSpPr>
-          <p:cNvPr id="9" name="Rectangle 8"/>
+          <p:cNvPr id="10" name="Rectangle 9"/>
           <p:cNvSpPr/>
           <p:nvPr/>
         </p:nvSpPr>
@@ -4905,7 +5049,7 @@
       </p:sp>
       <p:sp>
         <p:nvSpPr>
-          <p:cNvPr id="10" name="TextBox 9"/>
+          <p:cNvPr id="11" name="TextBox 10"/>
           <p:cNvSpPr txBox="1"/>
           <p:nvPr/>
         </p:nvSpPr>
@@ -4944,7 +5088,7 @@
       </p:sp>
       <p:sp>
         <p:nvSpPr>
-          <p:cNvPr id="11" name="TextBox 10"/>
+          <p:cNvPr id="12" name="TextBox 11"/>
           <p:cNvSpPr txBox="1"/>
           <p:nvPr/>
         </p:nvSpPr>
@@ -4983,7 +5127,7 @@
       </p:sp>
       <p:sp>
         <p:nvSpPr>
-          <p:cNvPr id="12" name="TextBox 11"/>
+          <p:cNvPr id="13" name="TextBox 12"/>
           <p:cNvSpPr txBox="1"/>
           <p:nvPr/>
         </p:nvSpPr>
@@ -5022,7 +5166,7 @@
       </p:sp>
       <p:sp>
         <p:nvSpPr>
-          <p:cNvPr id="13" name="Rectangle 12"/>
+          <p:cNvPr id="14" name="Rectangle 13"/>
           <p:cNvSpPr/>
           <p:nvPr/>
         </p:nvSpPr>
@@ -5066,7 +5210,7 @@
       </p:sp>
       <p:sp>
         <p:nvSpPr>
-          <p:cNvPr id="14" name="TextBox 13"/>
+          <p:cNvPr id="15" name="TextBox 14"/>
           <p:cNvSpPr txBox="1"/>
           <p:nvPr/>
         </p:nvSpPr>
@@ -5105,7 +5249,7 @@
       </p:sp>
       <p:sp>
         <p:nvSpPr>
-          <p:cNvPr id="15" name="TextBox 14"/>
+          <p:cNvPr id="16" name="TextBox 15"/>
           <p:cNvSpPr txBox="1"/>
           <p:nvPr/>
         </p:nvSpPr>
@@ -5144,7 +5288,7 @@
       </p:sp>
       <p:sp>
         <p:nvSpPr>
-          <p:cNvPr id="16" name="TextBox 15"/>
+          <p:cNvPr id="17" name="TextBox 16"/>
           <p:cNvSpPr txBox="1"/>
           <p:nvPr/>
         </p:nvSpPr>
@@ -5183,7 +5327,7 @@
       </p:sp>
       <p:sp>
         <p:nvSpPr>
-          <p:cNvPr id="17" name="Rectangle 16"/>
+          <p:cNvPr id="18" name="Rectangle 17"/>
           <p:cNvSpPr/>
           <p:nvPr/>
         </p:nvSpPr>
@@ -5227,7 +5371,7 @@
       </p:sp>
       <p:sp>
         <p:nvSpPr>
-          <p:cNvPr id="18" name="Rectangle 17"/>
+          <p:cNvPr id="19" name="Rectangle 18"/>
           <p:cNvSpPr/>
           <p:nvPr/>
         </p:nvSpPr>
@@ -5271,7 +5415,7 @@
       </p:sp>
       <p:sp>
         <p:nvSpPr>
-          <p:cNvPr id="19" name="TextBox 18"/>
+          <p:cNvPr id="20" name="TextBox 19"/>
           <p:cNvSpPr txBox="1"/>
           <p:nvPr/>
         </p:nvSpPr>
@@ -5310,7 +5454,7 @@
       </p:sp>
       <p:sp>
         <p:nvSpPr>
-          <p:cNvPr id="20" name="TextBox 19"/>
+          <p:cNvPr id="21" name="TextBox 20"/>
           <p:cNvSpPr txBox="1"/>
           <p:nvPr/>
         </p:nvSpPr>
@@ -5349,7 +5493,7 @@
       </p:sp>
       <p:sp>
         <p:nvSpPr>
-          <p:cNvPr id="21" name="TextBox 20"/>
+          <p:cNvPr id="22" name="TextBox 21"/>
           <p:cNvSpPr txBox="1"/>
           <p:nvPr/>
         </p:nvSpPr>
@@ -5388,7 +5532,7 @@
       </p:sp>
       <p:sp>
         <p:nvSpPr>
-          <p:cNvPr id="22" name="TextBox 21"/>
+          <p:cNvPr id="23" name="TextBox 22"/>
           <p:cNvSpPr txBox="1"/>
           <p:nvPr/>
         </p:nvSpPr>
@@ -5427,7 +5571,7 @@
       </p:sp>
       <p:sp>
         <p:nvSpPr>
-          <p:cNvPr id="23" name="TextBox 22"/>
+          <p:cNvPr id="24" name="TextBox 23"/>
           <p:cNvSpPr txBox="1"/>
           <p:nvPr/>
         </p:nvSpPr>
@@ -5466,7 +5610,7 @@
       </p:sp>
       <p:sp>
         <p:nvSpPr>
-          <p:cNvPr id="24" name="TextBox 23"/>
+          <p:cNvPr id="25" name="TextBox 24"/>
           <p:cNvSpPr txBox="1"/>
           <p:nvPr/>
         </p:nvSpPr>
@@ -5536,6 +5680,41 @@
           <p:nvPr/>
         </p:nvSpPr>
         <p:spPr>
+          <a:xfrm rot="19800000">
+            <a:off x="-762152" y="2423160"/>
+            <a:ext cx="13716000" cy="2011680"/>
+          </a:xfrm>
+          <a:prstGeom prst="rect">
+            <a:avLst/>
+          </a:prstGeom>
+          <a:noFill/>
+        </p:spPr>
+        <p:txBody>
+          <a:bodyPr wrap="none" lIns="0" rIns="0" tIns="0" bIns="0" anchor="ctr">
+            <a:spAutoFit/>
+          </a:bodyPr>
+          <a:lstStyle/>
+          <a:p>
+            <a:pPr algn="ctr"/>
+            <a:r>
+              <a:rPr sz="8000" b="1">
+                <a:solidFill>
+                  <a:srgbClr val="C8CCD8"/>
+                </a:solidFill>
+                <a:latin typeface="Cambria"/>
+              </a:rPr>
+              <a:t>WORKED EXAMPLE  ·  FICTIONAL BRAND</a:t>
+            </a:r>
+          </a:p>
+        </p:txBody>
+      </p:sp>
+      <p:sp>
+        <p:nvSpPr>
+          <p:cNvPr id="3" name="TextBox 2"/>
+          <p:cNvSpPr txBox="1"/>
+          <p:nvPr/>
+        </p:nvSpPr>
+        <p:spPr>
           <a:xfrm>
             <a:off x="457200" y="411480"/>
             <a:ext cx="7315200" cy="274320"/>
@@ -5570,7 +5749,7 @@
       </p:sp>
       <p:sp>
         <p:nvSpPr>
-          <p:cNvPr id="3" name="TextBox 2"/>
+          <p:cNvPr id="4" name="TextBox 3"/>
           <p:cNvSpPr txBox="1"/>
           <p:nvPr/>
         </p:nvSpPr>
@@ -5609,7 +5788,7 @@
       </p:sp>
       <p:sp>
         <p:nvSpPr>
-          <p:cNvPr id="4" name="Rectangle 3"/>
+          <p:cNvPr id="5" name="Rectangle 4"/>
           <p:cNvSpPr/>
           <p:nvPr/>
         </p:nvSpPr>
@@ -5655,7 +5834,7 @@
       </p:sp>
       <p:sp>
         <p:nvSpPr>
-          <p:cNvPr id="5" name="Rectangle 4"/>
+          <p:cNvPr id="6" name="Rectangle 5"/>
           <p:cNvSpPr/>
           <p:nvPr/>
         </p:nvSpPr>
@@ -5699,7 +5878,7 @@
       </p:sp>
       <p:sp>
         <p:nvSpPr>
-          <p:cNvPr id="6" name="TextBox 5"/>
+          <p:cNvPr id="7" name="TextBox 6"/>
           <p:cNvSpPr txBox="1"/>
           <p:nvPr/>
         </p:nvSpPr>
@@ -5738,7 +5917,7 @@
       </p:sp>
       <p:sp>
         <p:nvSpPr>
-          <p:cNvPr id="7" name="TextBox 6"/>
+          <p:cNvPr id="8" name="TextBox 7"/>
           <p:cNvSpPr txBox="1"/>
           <p:nvPr/>
         </p:nvSpPr>
@@ -5777,7 +5956,7 @@
       </p:sp>
       <p:sp>
         <p:nvSpPr>
-          <p:cNvPr id="8" name="TextBox 7"/>
+          <p:cNvPr id="9" name="TextBox 8"/>
           <p:cNvSpPr txBox="1"/>
           <p:nvPr/>
         </p:nvSpPr>
@@ -5816,7 +5995,7 @@
       </p:sp>
       <p:sp>
         <p:nvSpPr>
-          <p:cNvPr id="9" name="TextBox 8"/>
+          <p:cNvPr id="10" name="TextBox 9"/>
           <p:cNvSpPr txBox="1"/>
           <p:nvPr/>
         </p:nvSpPr>
@@ -5903,7 +6082,7 @@
       </p:sp>
       <p:sp>
         <p:nvSpPr>
-          <p:cNvPr id="10" name="Rectangle 9"/>
+          <p:cNvPr id="11" name="Rectangle 10"/>
           <p:cNvSpPr/>
           <p:nvPr/>
         </p:nvSpPr>
@@ -5947,7 +6126,7 @@
       </p:sp>
       <p:sp>
         <p:nvSpPr>
-          <p:cNvPr id="11" name="TextBox 10"/>
+          <p:cNvPr id="12" name="TextBox 11"/>
           <p:cNvSpPr txBox="1"/>
           <p:nvPr/>
         </p:nvSpPr>
@@ -5986,7 +6165,7 @@
       </p:sp>
       <p:sp>
         <p:nvSpPr>
-          <p:cNvPr id="12" name="Rectangle 11"/>
+          <p:cNvPr id="13" name="Rectangle 12"/>
           <p:cNvSpPr/>
           <p:nvPr/>
         </p:nvSpPr>
@@ -6032,7 +6211,7 @@
       </p:sp>
       <p:sp>
         <p:nvSpPr>
-          <p:cNvPr id="13" name="Rectangle 12"/>
+          <p:cNvPr id="14" name="Rectangle 13"/>
           <p:cNvSpPr/>
           <p:nvPr/>
         </p:nvSpPr>
@@ -6076,7 +6255,7 @@
       </p:sp>
       <p:sp>
         <p:nvSpPr>
-          <p:cNvPr id="14" name="TextBox 13"/>
+          <p:cNvPr id="15" name="TextBox 14"/>
           <p:cNvSpPr txBox="1"/>
           <p:nvPr/>
         </p:nvSpPr>
@@ -6115,7 +6294,7 @@
       </p:sp>
       <p:sp>
         <p:nvSpPr>
-          <p:cNvPr id="15" name="TextBox 14"/>
+          <p:cNvPr id="16" name="TextBox 15"/>
           <p:cNvSpPr txBox="1"/>
           <p:nvPr/>
         </p:nvSpPr>
@@ -6154,7 +6333,7 @@
       </p:sp>
       <p:sp>
         <p:nvSpPr>
-          <p:cNvPr id="16" name="TextBox 15"/>
+          <p:cNvPr id="17" name="TextBox 16"/>
           <p:cNvSpPr txBox="1"/>
           <p:nvPr/>
         </p:nvSpPr>
@@ -6193,7 +6372,7 @@
       </p:sp>
       <p:sp>
         <p:nvSpPr>
-          <p:cNvPr id="17" name="TextBox 16"/>
+          <p:cNvPr id="18" name="TextBox 17"/>
           <p:cNvSpPr txBox="1"/>
           <p:nvPr/>
         </p:nvSpPr>
@@ -6280,7 +6459,7 @@
       </p:sp>
       <p:sp>
         <p:nvSpPr>
-          <p:cNvPr id="18" name="Rectangle 17"/>
+          <p:cNvPr id="19" name="Rectangle 18"/>
           <p:cNvSpPr/>
           <p:nvPr/>
         </p:nvSpPr>
@@ -6324,7 +6503,7 @@
       </p:sp>
       <p:sp>
         <p:nvSpPr>
-          <p:cNvPr id="19" name="TextBox 18"/>
+          <p:cNvPr id="20" name="TextBox 19"/>
           <p:cNvSpPr txBox="1"/>
           <p:nvPr/>
         </p:nvSpPr>
@@ -6363,7 +6542,7 @@
       </p:sp>
       <p:sp>
         <p:nvSpPr>
-          <p:cNvPr id="20" name="Rectangle 19"/>
+          <p:cNvPr id="21" name="Rectangle 20"/>
           <p:cNvSpPr/>
           <p:nvPr/>
         </p:nvSpPr>
@@ -6409,7 +6588,7 @@
       </p:sp>
       <p:sp>
         <p:nvSpPr>
-          <p:cNvPr id="21" name="Rectangle 20"/>
+          <p:cNvPr id="22" name="Rectangle 21"/>
           <p:cNvSpPr/>
           <p:nvPr/>
         </p:nvSpPr>
@@ -6453,7 +6632,7 @@
       </p:sp>
       <p:sp>
         <p:nvSpPr>
-          <p:cNvPr id="22" name="TextBox 21"/>
+          <p:cNvPr id="23" name="TextBox 22"/>
           <p:cNvSpPr txBox="1"/>
           <p:nvPr/>
         </p:nvSpPr>
@@ -6492,7 +6671,7 @@
       </p:sp>
       <p:sp>
         <p:nvSpPr>
-          <p:cNvPr id="23" name="TextBox 22"/>
+          <p:cNvPr id="24" name="TextBox 23"/>
           <p:cNvSpPr txBox="1"/>
           <p:nvPr/>
         </p:nvSpPr>
@@ -6531,7 +6710,7 @@
       </p:sp>
       <p:sp>
         <p:nvSpPr>
-          <p:cNvPr id="24" name="TextBox 23"/>
+          <p:cNvPr id="25" name="TextBox 24"/>
           <p:cNvSpPr txBox="1"/>
           <p:nvPr/>
         </p:nvSpPr>
@@ -6570,7 +6749,7 @@
       </p:sp>
       <p:sp>
         <p:nvSpPr>
-          <p:cNvPr id="25" name="TextBox 24"/>
+          <p:cNvPr id="26" name="TextBox 25"/>
           <p:cNvSpPr txBox="1"/>
           <p:nvPr/>
         </p:nvSpPr>
@@ -6657,7 +6836,7 @@
       </p:sp>
       <p:sp>
         <p:nvSpPr>
-          <p:cNvPr id="26" name="Rectangle 25"/>
+          <p:cNvPr id="27" name="Rectangle 26"/>
           <p:cNvSpPr/>
           <p:nvPr/>
         </p:nvSpPr>
@@ -6701,7 +6880,7 @@
       </p:sp>
       <p:sp>
         <p:nvSpPr>
-          <p:cNvPr id="27" name="TextBox 26"/>
+          <p:cNvPr id="28" name="TextBox 27"/>
           <p:cNvSpPr txBox="1"/>
           <p:nvPr/>
         </p:nvSpPr>
@@ -6740,7 +6919,7 @@
       </p:sp>
       <p:sp>
         <p:nvSpPr>
-          <p:cNvPr id="28" name="TextBox 27"/>
+          <p:cNvPr id="29" name="TextBox 28"/>
           <p:cNvSpPr txBox="1"/>
           <p:nvPr/>
         </p:nvSpPr>
@@ -6779,7 +6958,7 @@
       </p:sp>
       <p:sp>
         <p:nvSpPr>
-          <p:cNvPr id="29" name="Rectangle 28"/>
+          <p:cNvPr id="30" name="Rectangle 29"/>
           <p:cNvSpPr/>
           <p:nvPr/>
         </p:nvSpPr>
@@ -6823,7 +7002,7 @@
       </p:sp>
       <p:sp>
         <p:nvSpPr>
-          <p:cNvPr id="30" name="Rectangle 29"/>
+          <p:cNvPr id="31" name="Rectangle 30"/>
           <p:cNvSpPr/>
           <p:nvPr/>
         </p:nvSpPr>
@@ -6867,7 +7046,7 @@
       </p:sp>
       <p:sp>
         <p:nvSpPr>
-          <p:cNvPr id="31" name="TextBox 30"/>
+          <p:cNvPr id="32" name="TextBox 31"/>
           <p:cNvSpPr txBox="1"/>
           <p:nvPr/>
         </p:nvSpPr>
@@ -6906,7 +7085,7 @@
       </p:sp>
       <p:sp>
         <p:nvSpPr>
-          <p:cNvPr id="32" name="TextBox 31"/>
+          <p:cNvPr id="33" name="TextBox 32"/>
           <p:cNvSpPr txBox="1"/>
           <p:nvPr/>
         </p:nvSpPr>
@@ -6945,7 +7124,7 @@
       </p:sp>
       <p:sp>
         <p:nvSpPr>
-          <p:cNvPr id="33" name="Rectangle 32"/>
+          <p:cNvPr id="34" name="Rectangle 33"/>
           <p:cNvSpPr/>
           <p:nvPr/>
         </p:nvSpPr>
@@ -6989,7 +7168,7 @@
       </p:sp>
       <p:sp>
         <p:nvSpPr>
-          <p:cNvPr id="34" name="TextBox 33"/>
+          <p:cNvPr id="35" name="TextBox 34"/>
           <p:cNvSpPr txBox="1"/>
           <p:nvPr/>
         </p:nvSpPr>
@@ -7028,7 +7207,7 @@
       </p:sp>
       <p:sp>
         <p:nvSpPr>
-          <p:cNvPr id="35" name="TextBox 34"/>
+          <p:cNvPr id="36" name="TextBox 35"/>
           <p:cNvSpPr txBox="1"/>
           <p:nvPr/>
         </p:nvSpPr>
@@ -7067,7 +7246,7 @@
       </p:sp>
       <p:sp>
         <p:nvSpPr>
-          <p:cNvPr id="36" name="Rectangle 35"/>
+          <p:cNvPr id="37" name="Rectangle 36"/>
           <p:cNvSpPr/>
           <p:nvPr/>
         </p:nvSpPr>
@@ -7111,7 +7290,7 @@
       </p:sp>
       <p:sp>
         <p:nvSpPr>
-          <p:cNvPr id="37" name="TextBox 36"/>
+          <p:cNvPr id="38" name="TextBox 37"/>
           <p:cNvSpPr txBox="1"/>
           <p:nvPr/>
         </p:nvSpPr>
@@ -7150,7 +7329,7 @@
       </p:sp>
       <p:sp>
         <p:nvSpPr>
-          <p:cNvPr id="38" name="TextBox 37"/>
+          <p:cNvPr id="39" name="TextBox 38"/>
           <p:cNvSpPr txBox="1"/>
           <p:nvPr/>
         </p:nvSpPr>
@@ -7189,7 +7368,7 @@
       </p:sp>
       <p:sp>
         <p:nvSpPr>
-          <p:cNvPr id="39" name="Rectangle 38"/>
+          <p:cNvPr id="40" name="Rectangle 39"/>
           <p:cNvSpPr/>
           <p:nvPr/>
         </p:nvSpPr>
@@ -7233,7 +7412,7 @@
       </p:sp>
       <p:sp>
         <p:nvSpPr>
-          <p:cNvPr id="40" name="TextBox 39"/>
+          <p:cNvPr id="41" name="TextBox 40"/>
           <p:cNvSpPr txBox="1"/>
           <p:nvPr/>
         </p:nvSpPr>
@@ -7272,7 +7451,7 @@
       </p:sp>
       <p:sp>
         <p:nvSpPr>
-          <p:cNvPr id="41" name="TextBox 40"/>
+          <p:cNvPr id="42" name="TextBox 41"/>
           <p:cNvSpPr txBox="1"/>
           <p:nvPr/>
         </p:nvSpPr>
@@ -7311,7 +7490,7 @@
       </p:sp>
       <p:sp>
         <p:nvSpPr>
-          <p:cNvPr id="42" name="Rectangle 41"/>
+          <p:cNvPr id="43" name="Rectangle 42"/>
           <p:cNvSpPr/>
           <p:nvPr/>
         </p:nvSpPr>
@@ -7355,7 +7534,7 @@
       </p:sp>
       <p:sp>
         <p:nvSpPr>
-          <p:cNvPr id="43" name="TextBox 42"/>
+          <p:cNvPr id="44" name="TextBox 43"/>
           <p:cNvSpPr txBox="1"/>
           <p:nvPr/>
         </p:nvSpPr>
@@ -7394,7 +7573,7 @@
       </p:sp>
       <p:sp>
         <p:nvSpPr>
-          <p:cNvPr id="44" name="TextBox 43"/>
+          <p:cNvPr id="45" name="TextBox 44"/>
           <p:cNvSpPr txBox="1"/>
           <p:nvPr/>
         </p:nvSpPr>
@@ -7433,7 +7612,7 @@
       </p:sp>
       <p:sp>
         <p:nvSpPr>
-          <p:cNvPr id="45" name="TextBox 44"/>
+          <p:cNvPr id="46" name="TextBox 45"/>
           <p:cNvSpPr txBox="1"/>
           <p:nvPr/>
         </p:nvSpPr>
@@ -7472,7 +7651,7 @@
       </p:sp>
       <p:sp>
         <p:nvSpPr>
-          <p:cNvPr id="46" name="TextBox 45"/>
+          <p:cNvPr id="47" name="TextBox 46"/>
           <p:cNvSpPr txBox="1"/>
           <p:nvPr/>
         </p:nvSpPr>
@@ -7542,6 +7721,41 @@
           <p:nvPr/>
         </p:nvSpPr>
         <p:spPr>
+          <a:xfrm rot="19800000">
+            <a:off x="-762152" y="2423160"/>
+            <a:ext cx="13716000" cy="2011680"/>
+          </a:xfrm>
+          <a:prstGeom prst="rect">
+            <a:avLst/>
+          </a:prstGeom>
+          <a:noFill/>
+        </p:spPr>
+        <p:txBody>
+          <a:bodyPr wrap="none" lIns="0" rIns="0" tIns="0" bIns="0" anchor="ctr">
+            <a:spAutoFit/>
+          </a:bodyPr>
+          <a:lstStyle/>
+          <a:p>
+            <a:pPr algn="ctr"/>
+            <a:r>
+              <a:rPr sz="8000" b="1">
+                <a:solidFill>
+                  <a:srgbClr val="C8CCD8"/>
+                </a:solidFill>
+                <a:latin typeface="Cambria"/>
+              </a:rPr>
+              <a:t>WORKED EXAMPLE  ·  FICTIONAL BRAND</a:t>
+            </a:r>
+          </a:p>
+        </p:txBody>
+      </p:sp>
+      <p:sp>
+        <p:nvSpPr>
+          <p:cNvPr id="3" name="TextBox 2"/>
+          <p:cNvSpPr txBox="1"/>
+          <p:nvPr/>
+        </p:nvSpPr>
+        <p:spPr>
           <a:xfrm>
             <a:off x="457200" y="411480"/>
             <a:ext cx="7315200" cy="274320"/>
@@ -7576,7 +7790,7 @@
       </p:sp>
       <p:sp>
         <p:nvSpPr>
-          <p:cNvPr id="3" name="TextBox 2"/>
+          <p:cNvPr id="4" name="TextBox 3"/>
           <p:cNvSpPr txBox="1"/>
           <p:nvPr/>
         </p:nvSpPr>
@@ -7615,7 +7829,7 @@
       </p:sp>
       <p:sp>
         <p:nvSpPr>
-          <p:cNvPr id="4" name="Rectangle 3"/>
+          <p:cNvPr id="5" name="Rectangle 4"/>
           <p:cNvSpPr/>
           <p:nvPr/>
         </p:nvSpPr>
@@ -7661,7 +7875,7 @@
       </p:sp>
       <p:sp>
         <p:nvSpPr>
-          <p:cNvPr id="5" name="TextBox 4"/>
+          <p:cNvPr id="6" name="TextBox 5"/>
           <p:cNvSpPr txBox="1"/>
           <p:nvPr/>
         </p:nvSpPr>
@@ -7700,7 +7914,7 @@
       </p:sp>
       <p:sp>
         <p:nvSpPr>
-          <p:cNvPr id="6" name="TextBox 5"/>
+          <p:cNvPr id="7" name="TextBox 6"/>
           <p:cNvSpPr txBox="1"/>
           <p:nvPr/>
         </p:nvSpPr>
@@ -7739,7 +7953,7 @@
       </p:sp>
       <p:sp>
         <p:nvSpPr>
-          <p:cNvPr id="7" name="Rectangle 6"/>
+          <p:cNvPr id="8" name="Rectangle 7"/>
           <p:cNvSpPr/>
           <p:nvPr/>
         </p:nvSpPr>
@@ -7783,7 +7997,7 @@
       </p:sp>
       <p:sp>
         <p:nvSpPr>
-          <p:cNvPr id="8" name="TextBox 7"/>
+          <p:cNvPr id="9" name="TextBox 8"/>
           <p:cNvSpPr txBox="1"/>
           <p:nvPr/>
         </p:nvSpPr>
@@ -7822,7 +8036,7 @@
       </p:sp>
       <p:sp>
         <p:nvSpPr>
-          <p:cNvPr id="9" name="Rectangle 8"/>
+          <p:cNvPr id="10" name="Rectangle 9"/>
           <p:cNvSpPr/>
           <p:nvPr/>
         </p:nvSpPr>
@@ -7866,7 +8080,7 @@
       </p:sp>
       <p:sp>
         <p:nvSpPr>
-          <p:cNvPr id="10" name="TextBox 9"/>
+          <p:cNvPr id="11" name="TextBox 10"/>
           <p:cNvSpPr txBox="1"/>
           <p:nvPr/>
         </p:nvSpPr>
@@ -7905,7 +8119,7 @@
       </p:sp>
       <p:sp>
         <p:nvSpPr>
-          <p:cNvPr id="11" name="Rectangle 10"/>
+          <p:cNvPr id="12" name="Rectangle 11"/>
           <p:cNvSpPr/>
           <p:nvPr/>
         </p:nvSpPr>
@@ -7949,7 +8163,7 @@
       </p:sp>
       <p:sp>
         <p:nvSpPr>
-          <p:cNvPr id="12" name="TextBox 11"/>
+          <p:cNvPr id="13" name="TextBox 12"/>
           <p:cNvSpPr txBox="1"/>
           <p:nvPr/>
         </p:nvSpPr>
@@ -7988,7 +8202,7 @@
       </p:sp>
       <p:sp>
         <p:nvSpPr>
-          <p:cNvPr id="13" name="Rectangle 12"/>
+          <p:cNvPr id="14" name="Rectangle 13"/>
           <p:cNvSpPr/>
           <p:nvPr/>
         </p:nvSpPr>
@@ -8032,7 +8246,7 @@
       </p:sp>
       <p:sp>
         <p:nvSpPr>
-          <p:cNvPr id="14" name="TextBox 13"/>
+          <p:cNvPr id="15" name="TextBox 14"/>
           <p:cNvSpPr txBox="1"/>
           <p:nvPr/>
         </p:nvSpPr>
@@ -8071,7 +8285,7 @@
       </p:sp>
       <p:sp>
         <p:nvSpPr>
-          <p:cNvPr id="15" name="Rectangle 14"/>
+          <p:cNvPr id="16" name="Rectangle 15"/>
           <p:cNvSpPr/>
           <p:nvPr/>
         </p:nvSpPr>
@@ -8115,7 +8329,7 @@
       </p:sp>
       <p:sp>
         <p:nvSpPr>
-          <p:cNvPr id="16" name="TextBox 15"/>
+          <p:cNvPr id="17" name="TextBox 16"/>
           <p:cNvSpPr txBox="1"/>
           <p:nvPr/>
         </p:nvSpPr>
@@ -8154,7 +8368,7 @@
       </p:sp>
       <p:sp>
         <p:nvSpPr>
-          <p:cNvPr id="17" name="TextBox 16"/>
+          <p:cNvPr id="18" name="TextBox 17"/>
           <p:cNvSpPr txBox="1"/>
           <p:nvPr/>
         </p:nvSpPr>
@@ -8193,7 +8407,7 @@
       </p:sp>
       <p:sp>
         <p:nvSpPr>
-          <p:cNvPr id="18" name="Rectangle 17"/>
+          <p:cNvPr id="19" name="Rectangle 18"/>
           <p:cNvSpPr/>
           <p:nvPr/>
         </p:nvSpPr>
@@ -8237,7 +8451,7 @@
       </p:sp>
       <p:sp>
         <p:nvSpPr>
-          <p:cNvPr id="19" name="TextBox 18"/>
+          <p:cNvPr id="20" name="TextBox 19"/>
           <p:cNvSpPr txBox="1"/>
           <p:nvPr/>
         </p:nvSpPr>
@@ -8276,7 +8490,7 @@
       </p:sp>
       <p:sp>
         <p:nvSpPr>
-          <p:cNvPr id="20" name="TextBox 19"/>
+          <p:cNvPr id="21" name="TextBox 20"/>
           <p:cNvSpPr txBox="1"/>
           <p:nvPr/>
         </p:nvSpPr>
@@ -8315,7 +8529,7 @@
       </p:sp>
       <p:sp>
         <p:nvSpPr>
-          <p:cNvPr id="21" name="TextBox 20"/>
+          <p:cNvPr id="22" name="TextBox 21"/>
           <p:cNvSpPr txBox="1"/>
           <p:nvPr/>
         </p:nvSpPr>
@@ -8354,7 +8568,7 @@
       </p:sp>
       <p:sp>
         <p:nvSpPr>
-          <p:cNvPr id="22" name="Rectangle 21"/>
+          <p:cNvPr id="23" name="Rectangle 22"/>
           <p:cNvSpPr/>
           <p:nvPr/>
         </p:nvSpPr>
@@ -8398,7 +8612,7 @@
       </p:sp>
       <p:sp>
         <p:nvSpPr>
-          <p:cNvPr id="23" name="TextBox 22"/>
+          <p:cNvPr id="24" name="TextBox 23"/>
           <p:cNvSpPr txBox="1"/>
           <p:nvPr/>
         </p:nvSpPr>
@@ -8437,7 +8651,7 @@
       </p:sp>
       <p:sp>
         <p:nvSpPr>
-          <p:cNvPr id="24" name="TextBox 23"/>
+          <p:cNvPr id="25" name="TextBox 24"/>
           <p:cNvSpPr txBox="1"/>
           <p:nvPr/>
         </p:nvSpPr>
@@ -8476,7 +8690,7 @@
       </p:sp>
       <p:sp>
         <p:nvSpPr>
-          <p:cNvPr id="25" name="TextBox 24"/>
+          <p:cNvPr id="26" name="TextBox 25"/>
           <p:cNvSpPr txBox="1"/>
           <p:nvPr/>
         </p:nvSpPr>
@@ -8515,7 +8729,7 @@
       </p:sp>
       <p:sp>
         <p:nvSpPr>
-          <p:cNvPr id="26" name="Rectangle 25"/>
+          <p:cNvPr id="27" name="Rectangle 26"/>
           <p:cNvSpPr/>
           <p:nvPr/>
         </p:nvSpPr>
@@ -8559,7 +8773,7 @@
       </p:sp>
       <p:sp>
         <p:nvSpPr>
-          <p:cNvPr id="27" name="TextBox 26"/>
+          <p:cNvPr id="28" name="TextBox 27"/>
           <p:cNvSpPr txBox="1"/>
           <p:nvPr/>
         </p:nvSpPr>
@@ -8598,7 +8812,7 @@
       </p:sp>
       <p:sp>
         <p:nvSpPr>
-          <p:cNvPr id="28" name="TextBox 27"/>
+          <p:cNvPr id="29" name="TextBox 28"/>
           <p:cNvSpPr txBox="1"/>
           <p:nvPr/>
         </p:nvSpPr>
@@ -8637,7 +8851,7 @@
       </p:sp>
       <p:sp>
         <p:nvSpPr>
-          <p:cNvPr id="29" name="TextBox 28"/>
+          <p:cNvPr id="30" name="TextBox 29"/>
           <p:cNvSpPr txBox="1"/>
           <p:nvPr/>
         </p:nvSpPr>
@@ -8677,7 +8891,7 @@
       </p:sp>
       <p:sp>
         <p:nvSpPr>
-          <p:cNvPr id="30" name="TextBox 29"/>
+          <p:cNvPr id="31" name="TextBox 30"/>
           <p:cNvSpPr txBox="1"/>
           <p:nvPr/>
         </p:nvSpPr>
@@ -8716,7 +8930,7 @@
       </p:sp>
       <p:sp>
         <p:nvSpPr>
-          <p:cNvPr id="31" name="TextBox 30"/>
+          <p:cNvPr id="32" name="TextBox 31"/>
           <p:cNvSpPr txBox="1"/>
           <p:nvPr/>
         </p:nvSpPr>
@@ -8755,7 +8969,7 @@
       </p:sp>
       <p:sp>
         <p:nvSpPr>
-          <p:cNvPr id="32" name="TextBox 31"/>
+          <p:cNvPr id="33" name="TextBox 32"/>
           <p:cNvSpPr txBox="1"/>
           <p:nvPr/>
         </p:nvSpPr>
@@ -8794,7 +9008,7 @@
       </p:sp>
       <p:sp>
         <p:nvSpPr>
-          <p:cNvPr id="33" name="TextBox 32"/>
+          <p:cNvPr id="34" name="TextBox 33"/>
           <p:cNvSpPr txBox="1"/>
           <p:nvPr/>
         </p:nvSpPr>
@@ -8833,7 +9047,7 @@
       </p:sp>
       <p:sp>
         <p:nvSpPr>
-          <p:cNvPr id="34" name="TextBox 33"/>
+          <p:cNvPr id="35" name="TextBox 34"/>
           <p:cNvSpPr txBox="1"/>
           <p:nvPr/>
         </p:nvSpPr>
@@ -8872,7 +9086,7 @@
       </p:sp>
       <p:sp>
         <p:nvSpPr>
-          <p:cNvPr id="35" name="TextBox 34"/>
+          <p:cNvPr id="36" name="TextBox 35"/>
           <p:cNvSpPr txBox="1"/>
           <p:nvPr/>
         </p:nvSpPr>
@@ -8911,7 +9125,7 @@
       </p:sp>
       <p:sp>
         <p:nvSpPr>
-          <p:cNvPr id="36" name="TextBox 35"/>
+          <p:cNvPr id="37" name="TextBox 36"/>
           <p:cNvSpPr txBox="1"/>
           <p:nvPr/>
         </p:nvSpPr>
@@ -8950,7 +9164,7 @@
       </p:sp>
       <p:sp>
         <p:nvSpPr>
-          <p:cNvPr id="37" name="TextBox 36"/>
+          <p:cNvPr id="38" name="TextBox 37"/>
           <p:cNvSpPr txBox="1"/>
           <p:nvPr/>
         </p:nvSpPr>
@@ -8989,7 +9203,7 @@
       </p:sp>
       <p:sp>
         <p:nvSpPr>
-          <p:cNvPr id="38" name="TextBox 37"/>
+          <p:cNvPr id="39" name="TextBox 38"/>
           <p:cNvSpPr txBox="1"/>
           <p:nvPr/>
         </p:nvSpPr>
@@ -9028,7 +9242,7 @@
       </p:sp>
       <p:sp>
         <p:nvSpPr>
-          <p:cNvPr id="39" name="TextBox 38"/>
+          <p:cNvPr id="40" name="TextBox 39"/>
           <p:cNvSpPr txBox="1"/>
           <p:nvPr/>
         </p:nvSpPr>
@@ -9067,7 +9281,7 @@
       </p:sp>
       <p:sp>
         <p:nvSpPr>
-          <p:cNvPr id="40" name="TextBox 39"/>
+          <p:cNvPr id="41" name="TextBox 40"/>
           <p:cNvSpPr txBox="1"/>
           <p:nvPr/>
         </p:nvSpPr>
@@ -9106,7 +9320,7 @@
       </p:sp>
       <p:sp>
         <p:nvSpPr>
-          <p:cNvPr id="41" name="TextBox 40"/>
+          <p:cNvPr id="42" name="TextBox 41"/>
           <p:cNvSpPr txBox="1"/>
           <p:nvPr/>
         </p:nvSpPr>
@@ -9176,6 +9390,41 @@
           <p:nvPr/>
         </p:nvSpPr>
         <p:spPr>
+          <a:xfrm rot="19800000">
+            <a:off x="-762152" y="2423160"/>
+            <a:ext cx="13716000" cy="2011680"/>
+          </a:xfrm>
+          <a:prstGeom prst="rect">
+            <a:avLst/>
+          </a:prstGeom>
+          <a:noFill/>
+        </p:spPr>
+        <p:txBody>
+          <a:bodyPr wrap="none" lIns="0" rIns="0" tIns="0" bIns="0" anchor="ctr">
+            <a:spAutoFit/>
+          </a:bodyPr>
+          <a:lstStyle/>
+          <a:p>
+            <a:pPr algn="ctr"/>
+            <a:r>
+              <a:rPr sz="8000" b="1">
+                <a:solidFill>
+                  <a:srgbClr val="C8CCD8"/>
+                </a:solidFill>
+                <a:latin typeface="Cambria"/>
+              </a:rPr>
+              <a:t>WORKED EXAMPLE  ·  FICTIONAL BRAND</a:t>
+            </a:r>
+          </a:p>
+        </p:txBody>
+      </p:sp>
+      <p:sp>
+        <p:nvSpPr>
+          <p:cNvPr id="3" name="TextBox 2"/>
+          <p:cNvSpPr txBox="1"/>
+          <p:nvPr/>
+        </p:nvSpPr>
+        <p:spPr>
           <a:xfrm>
             <a:off x="457200" y="411480"/>
             <a:ext cx="7315200" cy="274320"/>
@@ -9210,7 +9459,7 @@
       </p:sp>
       <p:sp>
         <p:nvSpPr>
-          <p:cNvPr id="3" name="TextBox 2"/>
+          <p:cNvPr id="4" name="TextBox 3"/>
           <p:cNvSpPr txBox="1"/>
           <p:nvPr/>
         </p:nvSpPr>
@@ -9249,7 +9498,7 @@
       </p:sp>
       <p:sp>
         <p:nvSpPr>
-          <p:cNvPr id="4" name="Rectangle 3"/>
+          <p:cNvPr id="5" name="Rectangle 4"/>
           <p:cNvSpPr/>
           <p:nvPr/>
         </p:nvSpPr>
@@ -9295,7 +9544,7 @@
       </p:sp>
       <p:sp>
         <p:nvSpPr>
-          <p:cNvPr id="5" name="Rectangle 4"/>
+          <p:cNvPr id="6" name="Rectangle 5"/>
           <p:cNvSpPr/>
           <p:nvPr/>
         </p:nvSpPr>
@@ -9339,7 +9588,7 @@
       </p:sp>
       <p:sp>
         <p:nvSpPr>
-          <p:cNvPr id="6" name="TextBox 5"/>
+          <p:cNvPr id="7" name="TextBox 6"/>
           <p:cNvSpPr txBox="1"/>
           <p:nvPr/>
         </p:nvSpPr>
@@ -9378,7 +9627,7 @@
       </p:sp>
       <p:sp>
         <p:nvSpPr>
-          <p:cNvPr id="7" name="TextBox 6"/>
+          <p:cNvPr id="8" name="TextBox 7"/>
           <p:cNvSpPr txBox="1"/>
           <p:nvPr/>
         </p:nvSpPr>
@@ -9417,7 +9666,7 @@
       </p:sp>
       <p:sp>
         <p:nvSpPr>
-          <p:cNvPr id="8" name="TextBox 7"/>
+          <p:cNvPr id="9" name="TextBox 8"/>
           <p:cNvSpPr txBox="1"/>
           <p:nvPr/>
         </p:nvSpPr>
@@ -9456,7 +9705,7 @@
       </p:sp>
       <p:sp>
         <p:nvSpPr>
-          <p:cNvPr id="9" name="TextBox 8"/>
+          <p:cNvPr id="10" name="TextBox 9"/>
           <p:cNvSpPr txBox="1"/>
           <p:nvPr/>
         </p:nvSpPr>
@@ -9495,7 +9744,7 @@
       </p:sp>
       <p:sp>
         <p:nvSpPr>
-          <p:cNvPr id="10" name="TextBox 9"/>
+          <p:cNvPr id="11" name="TextBox 10"/>
           <p:cNvSpPr txBox="1"/>
           <p:nvPr/>
         </p:nvSpPr>
@@ -9534,7 +9783,7 @@
       </p:sp>
       <p:sp>
         <p:nvSpPr>
-          <p:cNvPr id="11" name="TextBox 10"/>
+          <p:cNvPr id="12" name="TextBox 11"/>
           <p:cNvSpPr txBox="1"/>
           <p:nvPr/>
         </p:nvSpPr>
@@ -9573,7 +9822,7 @@
       </p:sp>
       <p:sp>
         <p:nvSpPr>
-          <p:cNvPr id="12" name="TextBox 11"/>
+          <p:cNvPr id="13" name="TextBox 12"/>
           <p:cNvSpPr txBox="1"/>
           <p:nvPr/>
         </p:nvSpPr>
@@ -9612,7 +9861,7 @@
       </p:sp>
       <p:sp>
         <p:nvSpPr>
-          <p:cNvPr id="13" name="TextBox 12"/>
+          <p:cNvPr id="14" name="TextBox 13"/>
           <p:cNvSpPr txBox="1"/>
           <p:nvPr/>
         </p:nvSpPr>
@@ -9651,7 +9900,7 @@
       </p:sp>
       <p:sp>
         <p:nvSpPr>
-          <p:cNvPr id="14" name="TextBox 13"/>
+          <p:cNvPr id="15" name="TextBox 14"/>
           <p:cNvSpPr txBox="1"/>
           <p:nvPr/>
         </p:nvSpPr>
@@ -9690,7 +9939,7 @@
       </p:sp>
       <p:sp>
         <p:nvSpPr>
-          <p:cNvPr id="15" name="TextBox 14"/>
+          <p:cNvPr id="16" name="TextBox 15"/>
           <p:cNvSpPr txBox="1"/>
           <p:nvPr/>
         </p:nvSpPr>
@@ -9729,7 +9978,7 @@
       </p:sp>
       <p:sp>
         <p:nvSpPr>
-          <p:cNvPr id="16" name="TextBox 15"/>
+          <p:cNvPr id="17" name="TextBox 16"/>
           <p:cNvSpPr txBox="1"/>
           <p:nvPr/>
         </p:nvSpPr>
@@ -9768,7 +10017,7 @@
       </p:sp>
       <p:sp>
         <p:nvSpPr>
-          <p:cNvPr id="17" name="TextBox 16"/>
+          <p:cNvPr id="18" name="TextBox 17"/>
           <p:cNvSpPr txBox="1"/>
           <p:nvPr/>
         </p:nvSpPr>
@@ -9807,7 +10056,7 @@
       </p:sp>
       <p:sp>
         <p:nvSpPr>
-          <p:cNvPr id="18" name="TextBox 17"/>
+          <p:cNvPr id="19" name="TextBox 18"/>
           <p:cNvSpPr txBox="1"/>
           <p:nvPr/>
         </p:nvSpPr>
@@ -9846,7 +10095,7 @@
       </p:sp>
       <p:sp>
         <p:nvSpPr>
-          <p:cNvPr id="19" name="Rectangle 18"/>
+          <p:cNvPr id="20" name="Rectangle 19"/>
           <p:cNvSpPr/>
           <p:nvPr/>
         </p:nvSpPr>
@@ -9890,7 +10139,7 @@
       </p:sp>
       <p:sp>
         <p:nvSpPr>
-          <p:cNvPr id="20" name="TextBox 19"/>
+          <p:cNvPr id="21" name="TextBox 20"/>
           <p:cNvSpPr txBox="1"/>
           <p:nvPr/>
         </p:nvSpPr>
@@ -9929,7 +10178,7 @@
       </p:sp>
       <p:sp>
         <p:nvSpPr>
-          <p:cNvPr id="21" name="TextBox 20"/>
+          <p:cNvPr id="22" name="TextBox 21"/>
           <p:cNvSpPr txBox="1"/>
           <p:nvPr/>
         </p:nvSpPr>
@@ -9968,7 +10217,7 @@
       </p:sp>
       <p:sp>
         <p:nvSpPr>
-          <p:cNvPr id="22" name="Rectangle 21"/>
+          <p:cNvPr id="23" name="Rectangle 22"/>
           <p:cNvSpPr/>
           <p:nvPr/>
         </p:nvSpPr>
@@ -10014,7 +10263,7 @@
       </p:sp>
       <p:sp>
         <p:nvSpPr>
-          <p:cNvPr id="23" name="Rectangle 22"/>
+          <p:cNvPr id="24" name="Rectangle 23"/>
           <p:cNvSpPr/>
           <p:nvPr/>
         </p:nvSpPr>
@@ -10058,7 +10307,7 @@
       </p:sp>
       <p:sp>
         <p:nvSpPr>
-          <p:cNvPr id="24" name="TextBox 23"/>
+          <p:cNvPr id="25" name="TextBox 24"/>
           <p:cNvSpPr txBox="1"/>
           <p:nvPr/>
         </p:nvSpPr>
@@ -10097,7 +10346,7 @@
       </p:sp>
       <p:sp>
         <p:nvSpPr>
-          <p:cNvPr id="25" name="TextBox 24"/>
+          <p:cNvPr id="26" name="TextBox 25"/>
           <p:cNvSpPr txBox="1"/>
           <p:nvPr/>
         </p:nvSpPr>
@@ -10136,7 +10385,7 @@
       </p:sp>
       <p:sp>
         <p:nvSpPr>
-          <p:cNvPr id="26" name="TextBox 25"/>
+          <p:cNvPr id="27" name="TextBox 26"/>
           <p:cNvSpPr txBox="1"/>
           <p:nvPr/>
         </p:nvSpPr>
@@ -10175,7 +10424,7 @@
       </p:sp>
       <p:sp>
         <p:nvSpPr>
-          <p:cNvPr id="27" name="TextBox 26"/>
+          <p:cNvPr id="28" name="TextBox 27"/>
           <p:cNvSpPr txBox="1"/>
           <p:nvPr/>
         </p:nvSpPr>
@@ -10214,7 +10463,7 @@
       </p:sp>
       <p:sp>
         <p:nvSpPr>
-          <p:cNvPr id="28" name="TextBox 27"/>
+          <p:cNvPr id="29" name="TextBox 28"/>
           <p:cNvSpPr txBox="1"/>
           <p:nvPr/>
         </p:nvSpPr>
@@ -10253,7 +10502,7 @@
       </p:sp>
       <p:sp>
         <p:nvSpPr>
-          <p:cNvPr id="29" name="TextBox 28"/>
+          <p:cNvPr id="30" name="TextBox 29"/>
           <p:cNvSpPr txBox="1"/>
           <p:nvPr/>
         </p:nvSpPr>
@@ -10292,7 +10541,7 @@
       </p:sp>
       <p:sp>
         <p:nvSpPr>
-          <p:cNvPr id="30" name="TextBox 29"/>
+          <p:cNvPr id="31" name="TextBox 30"/>
           <p:cNvSpPr txBox="1"/>
           <p:nvPr/>
         </p:nvSpPr>
@@ -10331,7 +10580,7 @@
       </p:sp>
       <p:sp>
         <p:nvSpPr>
-          <p:cNvPr id="31" name="TextBox 30"/>
+          <p:cNvPr id="32" name="TextBox 31"/>
           <p:cNvSpPr txBox="1"/>
           <p:nvPr/>
         </p:nvSpPr>
@@ -10370,7 +10619,7 @@
       </p:sp>
       <p:sp>
         <p:nvSpPr>
-          <p:cNvPr id="32" name="TextBox 31"/>
+          <p:cNvPr id="33" name="TextBox 32"/>
           <p:cNvSpPr txBox="1"/>
           <p:nvPr/>
         </p:nvSpPr>
@@ -10409,7 +10658,7 @@
       </p:sp>
       <p:sp>
         <p:nvSpPr>
-          <p:cNvPr id="33" name="TextBox 32"/>
+          <p:cNvPr id="34" name="TextBox 33"/>
           <p:cNvSpPr txBox="1"/>
           <p:nvPr/>
         </p:nvSpPr>
@@ -10448,7 +10697,7 @@
       </p:sp>
       <p:sp>
         <p:nvSpPr>
-          <p:cNvPr id="34" name="TextBox 33"/>
+          <p:cNvPr id="35" name="TextBox 34"/>
           <p:cNvSpPr txBox="1"/>
           <p:nvPr/>
         </p:nvSpPr>
@@ -10487,7 +10736,7 @@
       </p:sp>
       <p:sp>
         <p:nvSpPr>
-          <p:cNvPr id="35" name="TextBox 34"/>
+          <p:cNvPr id="36" name="TextBox 35"/>
           <p:cNvSpPr txBox="1"/>
           <p:nvPr/>
         </p:nvSpPr>
@@ -10526,7 +10775,7 @@
       </p:sp>
       <p:sp>
         <p:nvSpPr>
-          <p:cNvPr id="36" name="TextBox 35"/>
+          <p:cNvPr id="37" name="TextBox 36"/>
           <p:cNvSpPr txBox="1"/>
           <p:nvPr/>
         </p:nvSpPr>
@@ -10565,7 +10814,7 @@
       </p:sp>
       <p:sp>
         <p:nvSpPr>
-          <p:cNvPr id="37" name="Rectangle 36"/>
+          <p:cNvPr id="38" name="Rectangle 37"/>
           <p:cNvSpPr/>
           <p:nvPr/>
         </p:nvSpPr>
@@ -10609,7 +10858,7 @@
       </p:sp>
       <p:sp>
         <p:nvSpPr>
-          <p:cNvPr id="38" name="TextBox 37"/>
+          <p:cNvPr id="39" name="TextBox 38"/>
           <p:cNvSpPr txBox="1"/>
           <p:nvPr/>
         </p:nvSpPr>
@@ -10648,7 +10897,7 @@
       </p:sp>
       <p:sp>
         <p:nvSpPr>
-          <p:cNvPr id="39" name="TextBox 38"/>
+          <p:cNvPr id="40" name="TextBox 39"/>
           <p:cNvSpPr txBox="1"/>
           <p:nvPr/>
         </p:nvSpPr>
@@ -10687,7 +10936,7 @@
       </p:sp>
       <p:sp>
         <p:nvSpPr>
-          <p:cNvPr id="40" name="TextBox 39"/>
+          <p:cNvPr id="41" name="TextBox 40"/>
           <p:cNvSpPr txBox="1"/>
           <p:nvPr/>
         </p:nvSpPr>
@@ -10726,7 +10975,7 @@
       </p:sp>
       <p:sp>
         <p:nvSpPr>
-          <p:cNvPr id="41" name="TextBox 40"/>
+          <p:cNvPr id="42" name="TextBox 41"/>
           <p:cNvSpPr txBox="1"/>
           <p:nvPr/>
         </p:nvSpPr>
@@ -10796,6 +11045,41 @@
           <p:nvPr/>
         </p:nvSpPr>
         <p:spPr>
+          <a:xfrm rot="19800000">
+            <a:off x="-762152" y="2423160"/>
+            <a:ext cx="13716000" cy="2011680"/>
+          </a:xfrm>
+          <a:prstGeom prst="rect">
+            <a:avLst/>
+          </a:prstGeom>
+          <a:noFill/>
+        </p:spPr>
+        <p:txBody>
+          <a:bodyPr wrap="none" lIns="0" rIns="0" tIns="0" bIns="0" anchor="ctr">
+            <a:spAutoFit/>
+          </a:bodyPr>
+          <a:lstStyle/>
+          <a:p>
+            <a:pPr algn="ctr"/>
+            <a:r>
+              <a:rPr sz="8000" b="1">
+                <a:solidFill>
+                  <a:srgbClr val="4A558C"/>
+                </a:solidFill>
+                <a:latin typeface="Cambria"/>
+              </a:rPr>
+              <a:t>WORKED EXAMPLE  ·  FICTIONAL BRAND</a:t>
+            </a:r>
+          </a:p>
+        </p:txBody>
+      </p:sp>
+      <p:sp>
+        <p:nvSpPr>
+          <p:cNvPr id="3" name="TextBox 2"/>
+          <p:cNvSpPr txBox="1"/>
+          <p:nvPr/>
+        </p:nvSpPr>
+        <p:spPr>
           <a:xfrm>
             <a:off x="640080" y="548640"/>
             <a:ext cx="10058400" cy="274320"/>
@@ -10830,7 +11114,7 @@
       </p:sp>
       <p:sp>
         <p:nvSpPr>
-          <p:cNvPr id="3" name="TextBox 2"/>
+          <p:cNvPr id="4" name="TextBox 3"/>
           <p:cNvSpPr txBox="1"/>
           <p:nvPr/>
         </p:nvSpPr>
@@ -10869,7 +11153,7 @@
       </p:sp>
       <p:sp>
         <p:nvSpPr>
-          <p:cNvPr id="4" name="Rectangle 3"/>
+          <p:cNvPr id="5" name="Rectangle 4"/>
           <p:cNvSpPr/>
           <p:nvPr/>
         </p:nvSpPr>
@@ -10915,7 +11199,7 @@
       </p:sp>
       <p:sp>
         <p:nvSpPr>
-          <p:cNvPr id="5" name="TextBox 4"/>
+          <p:cNvPr id="6" name="TextBox 5"/>
           <p:cNvSpPr txBox="1"/>
           <p:nvPr/>
         </p:nvSpPr>
@@ -10954,7 +11238,7 @@
       </p:sp>
       <p:sp>
         <p:nvSpPr>
-          <p:cNvPr id="6" name="TextBox 5"/>
+          <p:cNvPr id="7" name="TextBox 6"/>
           <p:cNvSpPr txBox="1"/>
           <p:nvPr/>
         </p:nvSpPr>
@@ -10993,7 +11277,7 @@
       </p:sp>
       <p:sp>
         <p:nvSpPr>
-          <p:cNvPr id="7" name="TextBox 6"/>
+          <p:cNvPr id="8" name="TextBox 7"/>
           <p:cNvSpPr txBox="1"/>
           <p:nvPr/>
         </p:nvSpPr>
@@ -11032,7 +11316,7 @@
       </p:sp>
       <p:sp>
         <p:nvSpPr>
-          <p:cNvPr id="8" name="Rectangle 7"/>
+          <p:cNvPr id="9" name="Rectangle 8"/>
           <p:cNvSpPr/>
           <p:nvPr/>
         </p:nvSpPr>
@@ -11078,7 +11362,7 @@
       </p:sp>
       <p:sp>
         <p:nvSpPr>
-          <p:cNvPr id="9" name="TextBox 8"/>
+          <p:cNvPr id="10" name="TextBox 9"/>
           <p:cNvSpPr txBox="1"/>
           <p:nvPr/>
         </p:nvSpPr>
@@ -11117,7 +11401,7 @@
       </p:sp>
       <p:sp>
         <p:nvSpPr>
-          <p:cNvPr id="10" name="TextBox 9"/>
+          <p:cNvPr id="11" name="TextBox 10"/>
           <p:cNvSpPr txBox="1"/>
           <p:nvPr/>
         </p:nvSpPr>
@@ -11156,7 +11440,7 @@
       </p:sp>
       <p:sp>
         <p:nvSpPr>
-          <p:cNvPr id="11" name="TextBox 10"/>
+          <p:cNvPr id="12" name="TextBox 11"/>
           <p:cNvSpPr txBox="1"/>
           <p:nvPr/>
         </p:nvSpPr>
@@ -11195,7 +11479,7 @@
       </p:sp>
       <p:sp>
         <p:nvSpPr>
-          <p:cNvPr id="12" name="Rectangle 11"/>
+          <p:cNvPr id="13" name="Rectangle 12"/>
           <p:cNvSpPr/>
           <p:nvPr/>
         </p:nvSpPr>
@@ -11241,7 +11525,7 @@
       </p:sp>
       <p:sp>
         <p:nvSpPr>
-          <p:cNvPr id="13" name="TextBox 12"/>
+          <p:cNvPr id="14" name="TextBox 13"/>
           <p:cNvSpPr txBox="1"/>
           <p:nvPr/>
         </p:nvSpPr>
@@ -11280,7 +11564,7 @@
       </p:sp>
       <p:sp>
         <p:nvSpPr>
-          <p:cNvPr id="14" name="TextBox 13"/>
+          <p:cNvPr id="15" name="TextBox 14"/>
           <p:cNvSpPr txBox="1"/>
           <p:nvPr/>
         </p:nvSpPr>
@@ -11319,7 +11603,7 @@
       </p:sp>
       <p:sp>
         <p:nvSpPr>
-          <p:cNvPr id="15" name="TextBox 14"/>
+          <p:cNvPr id="16" name="TextBox 15"/>
           <p:cNvSpPr txBox="1"/>
           <p:nvPr/>
         </p:nvSpPr>
@@ -11358,7 +11642,7 @@
       </p:sp>
       <p:sp>
         <p:nvSpPr>
-          <p:cNvPr id="16" name="TextBox 15"/>
+          <p:cNvPr id="17" name="TextBox 16"/>
           <p:cNvSpPr txBox="1"/>
           <p:nvPr/>
         </p:nvSpPr>
@@ -11397,7 +11681,7 @@
       </p:sp>
       <p:sp>
         <p:nvSpPr>
-          <p:cNvPr id="17" name="TextBox 16"/>
+          <p:cNvPr id="18" name="TextBox 17"/>
           <p:cNvSpPr txBox="1"/>
           <p:nvPr/>
         </p:nvSpPr>
@@ -11436,7 +11720,7 @@
       </p:sp>
       <p:sp>
         <p:nvSpPr>
-          <p:cNvPr id="18" name="TextBox 17"/>
+          <p:cNvPr id="19" name="TextBox 18"/>
           <p:cNvSpPr txBox="1"/>
           <p:nvPr/>
         </p:nvSpPr>
@@ -11475,7 +11759,7 @@
       </p:sp>
       <p:sp>
         <p:nvSpPr>
-          <p:cNvPr id="19" name="TextBox 18"/>
+          <p:cNvPr id="20" name="TextBox 19"/>
           <p:cNvSpPr txBox="1"/>
           <p:nvPr/>
         </p:nvSpPr>
@@ -11514,7 +11798,7 @@
       </p:sp>
       <p:sp>
         <p:nvSpPr>
-          <p:cNvPr id="20" name="TextBox 19"/>
+          <p:cNvPr id="21" name="TextBox 20"/>
           <p:cNvSpPr txBox="1"/>
           <p:nvPr/>
         </p:nvSpPr>
@@ -11553,7 +11837,7 @@
       </p:sp>
       <p:sp>
         <p:nvSpPr>
-          <p:cNvPr id="21" name="TextBox 20"/>
+          <p:cNvPr id="22" name="TextBox 21"/>
           <p:cNvSpPr txBox="1"/>
           <p:nvPr/>
         </p:nvSpPr>
@@ -11592,7 +11876,7 @@
       </p:sp>
       <p:sp>
         <p:nvSpPr>
-          <p:cNvPr id="22" name="TextBox 21"/>
+          <p:cNvPr id="23" name="TextBox 22"/>
           <p:cNvSpPr txBox="1"/>
           <p:nvPr/>
         </p:nvSpPr>
@@ -11631,7 +11915,7 @@
       </p:sp>
       <p:sp>
         <p:nvSpPr>
-          <p:cNvPr id="23" name="TextBox 22"/>
+          <p:cNvPr id="24" name="TextBox 23"/>
           <p:cNvSpPr txBox="1"/>
           <p:nvPr/>
         </p:nvSpPr>
@@ -11670,7 +11954,7 @@
       </p:sp>
       <p:sp>
         <p:nvSpPr>
-          <p:cNvPr id="24" name="TextBox 23"/>
+          <p:cNvPr id="25" name="TextBox 24"/>
           <p:cNvSpPr txBox="1"/>
           <p:nvPr/>
         </p:nvSpPr>
@@ -11709,7 +11993,7 @@
       </p:sp>
       <p:sp>
         <p:nvSpPr>
-          <p:cNvPr id="25" name="TextBox 24"/>
+          <p:cNvPr id="26" name="TextBox 25"/>
           <p:cNvSpPr txBox="1"/>
           <p:nvPr/>
         </p:nvSpPr>
@@ -11748,7 +12032,7 @@
       </p:sp>
       <p:sp>
         <p:nvSpPr>
-          <p:cNvPr id="26" name="TextBox 25"/>
+          <p:cNvPr id="27" name="TextBox 26"/>
           <p:cNvSpPr txBox="1"/>
           <p:nvPr/>
         </p:nvSpPr>
@@ -11787,7 +12071,7 @@
       </p:sp>
       <p:sp>
         <p:nvSpPr>
-          <p:cNvPr id="27" name="TextBox 26"/>
+          <p:cNvPr id="28" name="TextBox 27"/>
           <p:cNvSpPr txBox="1"/>
           <p:nvPr/>
         </p:nvSpPr>

</xml_diff>